<commit_message>
fix(site): consistency review - Projects back as its own section with example projects; deliverable 2 possible without code; kick-off slot assigned by teachers; period ends 13 December; cross-references to the new sections; guide PDF and slides rebuilt
Co-Authored-By: Claude Opus 5.5 (1M context) <noreply@anthropic.com>
</commit_message>
<xml_diff>
--- a/docs/slides/COIL_1_kickoff.pptx
+++ b/docs/slides/COIL_1_kickoff.pptx
@@ -6891,7 +6891,7 @@
                           <a:ea typeface="Calibri" pitchFamily="34" charset="-122"/>
                           <a:cs typeface="Calibri" pitchFamily="34" charset="-120"/>
                         </a:rPr>
-                        <a:t>First team meeting in break-out rooms (teams announced by the teachers, with students from the three universities): introduce yourself with your fact about your country, choose a communication channel and a weekly meeting time.</a:t>
+                        <a:t>First team meeting in break-out rooms (teams and their slot are announced by the teachers before the session, with students from the three universities): introduce yourself with your fact about your country, choose a communication channel and a weekly meeting time.</a:t>
                       </a:r>
                       <a:endParaRPr lang="en-US" sz="1150" dirty="0">
                         <a:latin typeface="Calibri" charset="0"/>
@@ -9699,7 +9699,7 @@
                 <a:ea typeface="Georgia" pitchFamily="34" charset="-122"/>
                 <a:cs typeface="Georgia" pitchFamily="34" charset="-120"/>
               </a:rPr>
-              <a:t>Nine weeks · 12 October – 11 December 2026</a:t>
+              <a:t>Nine weeks · 12 October – 13 December 2026</a:t>
             </a:r>
             <a:endParaRPr lang="en-US" sz="2400" dirty="0"/>
           </a:p>
@@ -12011,7 +12011,7 @@
                 <a:ea typeface="Calibri" pitchFamily="34" charset="-122"/>
                 <a:cs typeface="Calibri" pitchFamily="34" charset="-120"/>
               </a:rPr>
-              <a:t>One PDF, maximum 2 pages (use the templates in the guide)</a:t>
+              <a:t>One PDF, maximum 2 pages (use the templates in the Submit section)</a:t>
             </a:r>
             <a:endParaRPr lang="en-US" sz="1000" dirty="0"/>
           </a:p>
@@ -12288,7 +12288,7 @@
                 <a:ea typeface="Calibri" pitchFamily="34" charset="-122"/>
                 <a:cs typeface="Calibri" pitchFamily="34" charset="-120"/>
               </a:rPr>
-              <a:t>Python or R notebook (.ipynb, .Rmd or Quarto), or Gretl script (.inp) with its output, + exported HTML or PDF + your dataset (CSV or Excel)</a:t>
+              <a:t>Your analysis file (Python or R notebook, Gretl script or session, or Power BI file) + a PDF or HTML report with all results + your dataset (CSV or Excel)</a:t>
             </a:r>
             <a:endParaRPr lang="en-US" sz="1000" dirty="0"/>
           </a:p>
@@ -13127,7 +13127,7 @@
                 <a:ea typeface="Calibri" pitchFamily="34" charset="-122"/>
                 <a:cs typeface="Calibri" pitchFamily="34" charset="-120"/>
               </a:rPr>
-              <a:t>One PDF, maximum 2 pages (use the templates in the guide)</a:t>
+              <a:t>One PDF, maximum 2 pages (use the templates in the Submit section)</a:t>
             </a:r>
             <a:endParaRPr lang="en-US" sz="1150" dirty="0"/>
           </a:p>

</xml_diff>

<commit_message>
fix(site): extra points at TUKE and UCG are +20/100; rebuild slides and guide
Co-Authored-By: Claude Opus 5.5 (1M context) <noreply@anthropic.com>
</commit_message>
<xml_diff>
--- a/docs/slides/COIL_1_kickoff.pptx
+++ b/docs/slides/COIL_1_kickoff.pptx
@@ -4612,7 +4612,7 @@
                 <a:ea typeface="Georgia" pitchFamily="34" charset="-122"/>
                 <a:cs typeface="Georgia" pitchFamily="34" charset="-120"/>
               </a:rPr>
-              <a:t>+10</a:t>
+              <a:t>+20</a:t>
             </a:r>
             <a:endParaRPr lang="en-US" sz="4800" dirty="0"/>
           </a:p>
@@ -7218,7 +7218,7 @@
         </p:blipFill>
         <p:spPr>
           <a:xfrm>
-            <a:off x="708660" y="1234440"/>
+            <a:off x="571500" y="1234440"/>
             <a:ext cx="1143000" cy="1143000"/>
           </a:xfrm>
           <a:prstGeom prst="ellipse">
@@ -7235,7 +7235,7 @@
         <p:spPr>
           <a:xfrm>
             <a:off x="457200" y="2468880"/>
-            <a:ext cx="1645920" cy="457200"/>
+            <a:ext cx="1371600" cy="457200"/>
           </a:xfrm>
           <a:prstGeom prst="rect">
             <a:avLst/>
@@ -7274,7 +7274,7 @@
         <p:spPr>
           <a:xfrm>
             <a:off x="457200" y="2926080"/>
-            <a:ext cx="1645920" cy="411480"/>
+            <a:ext cx="1371600" cy="411480"/>
           </a:xfrm>
           <a:prstGeom prst="rect">
             <a:avLst/>
@@ -7313,7 +7313,7 @@
         <p:spPr>
           <a:xfrm>
             <a:off x="457200" y="3337560"/>
-            <a:ext cx="1645920" cy="274320"/>
+            <a:ext cx="1371600" cy="274320"/>
           </a:xfrm>
           <a:prstGeom prst="rect">
             <a:avLst/>
@@ -7358,7 +7358,7 @@
         </p:blipFill>
         <p:spPr>
           <a:xfrm>
-            <a:off x="2354580" y="1234440"/>
+            <a:off x="1943100" y="1234440"/>
             <a:ext cx="1143000" cy="1143000"/>
           </a:xfrm>
           <a:prstGeom prst="ellipse">
@@ -7374,8 +7374,8 @@
         </p:nvSpPr>
         <p:spPr>
           <a:xfrm>
-            <a:off x="2103120" y="2468880"/>
-            <a:ext cx="1645920" cy="457200"/>
+            <a:off x="1828800" y="2468880"/>
+            <a:ext cx="1371600" cy="457200"/>
           </a:xfrm>
           <a:prstGeom prst="rect">
             <a:avLst/>
@@ -7413,8 +7413,8 @@
         </p:nvSpPr>
         <p:spPr>
           <a:xfrm>
-            <a:off x="2103120" y="2926080"/>
-            <a:ext cx="1645920" cy="411480"/>
+            <a:off x="1828800" y="2926080"/>
+            <a:ext cx="1371600" cy="411480"/>
           </a:xfrm>
           <a:prstGeom prst="rect">
             <a:avLst/>
@@ -7452,8 +7452,8 @@
         </p:nvSpPr>
         <p:spPr>
           <a:xfrm>
-            <a:off x="2103120" y="3337560"/>
-            <a:ext cx="1645920" cy="274320"/>
+            <a:off x="1828800" y="3337560"/>
+            <a:ext cx="1371600" cy="274320"/>
           </a:xfrm>
           <a:prstGeom prst="rect">
             <a:avLst/>
@@ -7498,7 +7498,7 @@
         </p:blipFill>
         <p:spPr>
           <a:xfrm>
-            <a:off x="4000500" y="1234440"/>
+            <a:off x="3314700" y="1234440"/>
             <a:ext cx="1143000" cy="1143000"/>
           </a:xfrm>
           <a:prstGeom prst="ellipse">
@@ -7514,8 +7514,8 @@
         </p:nvSpPr>
         <p:spPr>
           <a:xfrm>
-            <a:off x="3749040" y="2468880"/>
-            <a:ext cx="1645920" cy="457200"/>
+            <a:off x="3200400" y="2468880"/>
+            <a:ext cx="1371600" cy="457200"/>
           </a:xfrm>
           <a:prstGeom prst="rect">
             <a:avLst/>
@@ -7553,8 +7553,8 @@
         </p:nvSpPr>
         <p:spPr>
           <a:xfrm>
-            <a:off x="3749040" y="2926080"/>
-            <a:ext cx="1645920" cy="411480"/>
+            <a:off x="3200400" y="2926080"/>
+            <a:ext cx="1371600" cy="411480"/>
           </a:xfrm>
           <a:prstGeom prst="rect">
             <a:avLst/>
@@ -7592,8 +7592,8 @@
         </p:nvSpPr>
         <p:spPr>
           <a:xfrm>
-            <a:off x="3749040" y="3337560"/>
-            <a:ext cx="1645920" cy="274320"/>
+            <a:off x="3200400" y="3337560"/>
+            <a:ext cx="1371600" cy="274320"/>
           </a:xfrm>
           <a:prstGeom prst="rect">
             <a:avLst/>
@@ -7625,7 +7625,7 @@
       </p:sp>
       <p:pic>
         <p:nvPicPr>
-          <p:cNvPr id="17" name="Image 3" descr="C:\Users\danir\Desktop\COIL Ulysseus\site\img\team\dana-palova.jpg">    </p:cNvPr>
+          <p:cNvPr id="17" name="Image 3" descr="C:\Users\danir\Desktop\COIL Ulysseus\site\img\team\victor-perez-leon.jpg">    </p:cNvPr>
           <p:cNvPicPr>
             <a:picLocks noChangeAspect="1"/>
           </p:cNvPicPr>
@@ -7638,7 +7638,7 @@
         </p:blipFill>
         <p:spPr>
           <a:xfrm>
-            <a:off x="5646420" y="1234440"/>
+            <a:off x="4686300" y="1234440"/>
             <a:ext cx="1143000" cy="1143000"/>
           </a:xfrm>
           <a:prstGeom prst="ellipse">
@@ -7654,8 +7654,8 @@
         </p:nvSpPr>
         <p:spPr>
           <a:xfrm>
-            <a:off x="5394960" y="2468880"/>
-            <a:ext cx="1645920" cy="457200"/>
+            <a:off x="4572000" y="2468880"/>
+            <a:ext cx="1371600" cy="457200"/>
           </a:xfrm>
           <a:prstGeom prst="rect">
             <a:avLst/>
@@ -7679,7 +7679,7 @@
                 <a:ea typeface="Calibri" pitchFamily="34" charset="-122"/>
                 <a:cs typeface="Calibri" pitchFamily="34" charset="-120"/>
               </a:rPr>
-              <a:t>Dana Paľová</a:t>
+              <a:t>Víctor Ernesto Pérez León</a:t>
             </a:r>
             <a:endParaRPr lang="en-US" sz="1250" dirty="0"/>
           </a:p>
@@ -7693,8 +7693,8 @@
         </p:nvSpPr>
         <p:spPr>
           <a:xfrm>
-            <a:off x="5394960" y="2926080"/>
-            <a:ext cx="1645920" cy="411480"/>
+            <a:off x="4572000" y="2926080"/>
+            <a:ext cx="1371600" cy="411480"/>
           </a:xfrm>
           <a:prstGeom prst="rect">
             <a:avLst/>
@@ -7718,7 +7718,7 @@
                 <a:ea typeface="Calibri" pitchFamily="34" charset="-122"/>
                 <a:cs typeface="Calibri" pitchFamily="34" charset="-120"/>
               </a:rPr>
-              <a:t>Technical University of Košice</a:t>
+              <a:t>University of Seville</a:t>
             </a:r>
             <a:endParaRPr lang="en-US" sz="1050" dirty="0"/>
           </a:p>
@@ -7732,8 +7732,8 @@
         </p:nvSpPr>
         <p:spPr>
           <a:xfrm>
-            <a:off x="5394960" y="3337560"/>
-            <a:ext cx="1645920" cy="274320"/>
+            <a:off x="4572000" y="3337560"/>
+            <a:ext cx="1371600" cy="274320"/>
           </a:xfrm>
           <a:prstGeom prst="rect">
             <a:avLst/>
@@ -7757,7 +7757,7 @@
                 <a:ea typeface="Calibri" pitchFamily="34" charset="-122"/>
                 <a:cs typeface="Calibri" pitchFamily="34" charset="-120"/>
               </a:rPr>
-              <a:t>dana.palova@tuke.sk</a:t>
+              <a:t>vpleon@us.es</a:t>
             </a:r>
             <a:endParaRPr lang="en-US" sz="950" dirty="0"/>
           </a:p>
@@ -7765,7 +7765,7 @@
       </p:sp>
       <p:pic>
         <p:nvPicPr>
-          <p:cNvPr id="21" name="Image 4" descr="C:\Users\danir\Desktop\COIL Ulysseus\site\img\team\victor-perez-leon.jpg">    </p:cNvPr>
+          <p:cNvPr id="21" name="Image 4" descr="C:\Users\danir\Desktop\COIL Ulysseus\site\img\team\dana-palova.jpg">    </p:cNvPr>
           <p:cNvPicPr>
             <a:picLocks noChangeAspect="1"/>
           </p:cNvPicPr>
@@ -7778,7 +7778,7 @@
         </p:blipFill>
         <p:spPr>
           <a:xfrm>
-            <a:off x="7292340" y="1234440"/>
+            <a:off x="6057900" y="1234440"/>
             <a:ext cx="1143000" cy="1143000"/>
           </a:xfrm>
           <a:prstGeom prst="ellipse">
@@ -7794,8 +7794,8 @@
         </p:nvSpPr>
         <p:spPr>
           <a:xfrm>
-            <a:off x="7040880" y="2468880"/>
-            <a:ext cx="1645920" cy="457200"/>
+            <a:off x="5943600" y="2468880"/>
+            <a:ext cx="1371600" cy="457200"/>
           </a:xfrm>
           <a:prstGeom prst="rect">
             <a:avLst/>
@@ -7819,7 +7819,7 @@
                 <a:ea typeface="Calibri" pitchFamily="34" charset="-122"/>
                 <a:cs typeface="Calibri" pitchFamily="34" charset="-120"/>
               </a:rPr>
-              <a:t>Víctor Ernesto Pérez León</a:t>
+              <a:t>Dana Paľová</a:t>
             </a:r>
             <a:endParaRPr lang="en-US" sz="1250" dirty="0"/>
           </a:p>
@@ -7833,8 +7833,8 @@
         </p:nvSpPr>
         <p:spPr>
           <a:xfrm>
-            <a:off x="7040880" y="2926080"/>
-            <a:ext cx="1645920" cy="411480"/>
+            <a:off x="5943600" y="2926080"/>
+            <a:ext cx="1371600" cy="411480"/>
           </a:xfrm>
           <a:prstGeom prst="rect">
             <a:avLst/>
@@ -7858,7 +7858,7 @@
                 <a:ea typeface="Calibri" pitchFamily="34" charset="-122"/>
                 <a:cs typeface="Calibri" pitchFamily="34" charset="-120"/>
               </a:rPr>
-              <a:t>University of Seville</a:t>
+              <a:t>Technical University of Košice</a:t>
             </a:r>
             <a:endParaRPr lang="en-US" sz="1050" dirty="0"/>
           </a:p>
@@ -7872,8 +7872,8 @@
         </p:nvSpPr>
         <p:spPr>
           <a:xfrm>
-            <a:off x="7040880" y="3337560"/>
-            <a:ext cx="1645920" cy="274320"/>
+            <a:off x="5943600" y="3337560"/>
+            <a:ext cx="1371600" cy="274320"/>
           </a:xfrm>
           <a:prstGeom prst="rect">
             <a:avLst/>
@@ -7897,15 +7897,155 @@
                 <a:ea typeface="Calibri" pitchFamily="34" charset="-122"/>
                 <a:cs typeface="Calibri" pitchFamily="34" charset="-120"/>
               </a:rPr>
-              <a:t>vpleon@us.es</a:t>
+              <a:t>dana.palova@tuke.sk</a:t>
             </a:r>
             <a:endParaRPr lang="en-US" sz="950" dirty="0"/>
           </a:p>
         </p:txBody>
       </p:sp>
-      <p:sp>
-        <p:nvSpPr>
-          <p:cNvPr id="25" name="Text 18"/>
+      <p:pic>
+        <p:nvPicPr>
+          <p:cNvPr id="25" name="Image 5" descr="C:\Users\danir\Desktop\COIL Ulysseus\site\img\team\tamara-backovic.jpg">    </p:cNvPr>
+          <p:cNvPicPr>
+            <a:picLocks noChangeAspect="1"/>
+          </p:cNvPicPr>
+          <p:nvPr/>
+        </p:nvPicPr>
+        <p:blipFill>
+          <a:blip r:embed="rId6"/>
+          <a:srcRect l="0" r="0" t="0" b="0"/>
+          <a:stretch/>
+        </p:blipFill>
+        <p:spPr>
+          <a:xfrm>
+            <a:off x="7429500" y="1234440"/>
+            <a:ext cx="1143000" cy="1143000"/>
+          </a:xfrm>
+          <a:prstGeom prst="ellipse">
+            <a:avLst/>
+          </a:prstGeom>
+        </p:spPr>
+      </p:pic>
+      <p:sp>
+        <p:nvSpPr>
+          <p:cNvPr id="26" name="Text 18"/>
+          <p:cNvSpPr/>
+          <p:nvPr/>
+        </p:nvSpPr>
+        <p:spPr>
+          <a:xfrm>
+            <a:off x="7315200" y="2468880"/>
+            <a:ext cx="1371600" cy="457200"/>
+          </a:xfrm>
+          <a:prstGeom prst="rect">
+            <a:avLst/>
+          </a:prstGeom>
+          <a:noFill/>
+          <a:ln/>
+        </p:spPr>
+        <p:txBody>
+          <a:bodyPr wrap="square" lIns="0" tIns="0" rIns="0" bIns="0" rtlCol="0" anchor="t"/>
+          <a:lstStyle/>
+          <a:p>
+            <a:pPr algn="ctr" indent="0" marL="0">
+              <a:buNone/>
+            </a:pPr>
+            <a:r>
+              <a:rPr lang="en-US" sz="1250" b="1" dirty="0">
+                <a:solidFill>
+                  <a:srgbClr val="312A63"/>
+                </a:solidFill>
+                <a:latin typeface="Calibri" pitchFamily="34" charset="0"/>
+                <a:ea typeface="Calibri" pitchFamily="34" charset="-122"/>
+                <a:cs typeface="Calibri" pitchFamily="34" charset="-120"/>
+              </a:rPr>
+              <a:t>Tamara Backović</a:t>
+            </a:r>
+            <a:endParaRPr lang="en-US" sz="1250" dirty="0"/>
+          </a:p>
+        </p:txBody>
+      </p:sp>
+      <p:sp>
+        <p:nvSpPr>
+          <p:cNvPr id="27" name="Text 19"/>
+          <p:cNvSpPr/>
+          <p:nvPr/>
+        </p:nvSpPr>
+        <p:spPr>
+          <a:xfrm>
+            <a:off x="7315200" y="2926080"/>
+            <a:ext cx="1371600" cy="411480"/>
+          </a:xfrm>
+          <a:prstGeom prst="rect">
+            <a:avLst/>
+          </a:prstGeom>
+          <a:noFill/>
+          <a:ln/>
+        </p:spPr>
+        <p:txBody>
+          <a:bodyPr wrap="square" lIns="0" tIns="0" rIns="0" bIns="0" rtlCol="0" anchor="t"/>
+          <a:lstStyle/>
+          <a:p>
+            <a:pPr algn="ctr" indent="0" marL="0">
+              <a:buNone/>
+            </a:pPr>
+            <a:r>
+              <a:rPr lang="en-US" sz="1050" dirty="0">
+                <a:solidFill>
+                  <a:srgbClr val="E55A5A"/>
+                </a:solidFill>
+                <a:latin typeface="Calibri" pitchFamily="34" charset="0"/>
+                <a:ea typeface="Calibri" pitchFamily="34" charset="-122"/>
+                <a:cs typeface="Calibri" pitchFamily="34" charset="-120"/>
+              </a:rPr>
+              <a:t>University of Montenegro</a:t>
+            </a:r>
+            <a:endParaRPr lang="en-US" sz="1050" dirty="0"/>
+          </a:p>
+        </p:txBody>
+      </p:sp>
+      <p:sp>
+        <p:nvSpPr>
+          <p:cNvPr id="28" name="Text 20"/>
+          <p:cNvSpPr/>
+          <p:nvPr/>
+        </p:nvSpPr>
+        <p:spPr>
+          <a:xfrm>
+            <a:off x="7315200" y="3337560"/>
+            <a:ext cx="1371600" cy="274320"/>
+          </a:xfrm>
+          <a:prstGeom prst="rect">
+            <a:avLst/>
+          </a:prstGeom>
+          <a:noFill/>
+          <a:ln/>
+        </p:spPr>
+        <p:txBody>
+          <a:bodyPr wrap="square" lIns="0" tIns="0" rIns="0" bIns="0" rtlCol="0" anchor="ctr"/>
+          <a:lstStyle/>
+          <a:p>
+            <a:pPr algn="ctr" indent="0" marL="0">
+              <a:buNone/>
+            </a:pPr>
+            <a:r>
+              <a:rPr lang="en-US" sz="950" dirty="0">
+                <a:solidFill>
+                  <a:srgbClr val="6B6880"/>
+                </a:solidFill>
+                <a:latin typeface="Calibri" pitchFamily="34" charset="0"/>
+                <a:ea typeface="Calibri" pitchFamily="34" charset="-122"/>
+                <a:cs typeface="Calibri" pitchFamily="34" charset="-120"/>
+              </a:rPr>
+              <a:t>tassabacc@ucg.ac.me</a:t>
+            </a:r>
+            <a:endParaRPr lang="en-US" sz="950" dirty="0"/>
+          </a:p>
+        </p:txBody>
+      </p:sp>
+      <p:sp>
+        <p:nvSpPr>
+          <p:cNvPr id="29" name="Text 21"/>
           <p:cNvSpPr/>
           <p:nvPr/>
         </p:nvSpPr>

</xml_diff>

<commit_message>
feat(site): move COIL to 8 weeks (19 Oct - 13 Dec), final presentation in week 8
Co-Authored-By: Claude Opus 5.5 (1M context) <noreply@anthropic.com>
</commit_message>
<xml_diff>
--- a/docs/slides/COIL_1_kickoff.pptx
+++ b/docs/slides/COIL_1_kickoff.pptx
@@ -2363,7 +2363,7 @@
                 <a:ea typeface="Calibri" pitchFamily="34" charset="-122"/>
                 <a:cs typeface="Calibri" pitchFamily="34" charset="-120"/>
               </a:rPr>
-              <a:t>Week 1 · 12 Oct – 18 Oct 2026 · 45 minutes · Microsoft Teams</a:t>
+              <a:t>Week 1 · 19 Oct – 25 Oct 2026 · 45 minutes · Microsoft Teams</a:t>
             </a:r>
             <a:endParaRPr lang="en-US" sz="1200" dirty="0"/>
           </a:p>
@@ -6074,7 +6074,7 @@
                 <a:ea typeface="Calibri" pitchFamily="34" charset="-122"/>
                 <a:cs typeface="Calibri" pitchFamily="34" charset="-120"/>
               </a:rPr>
-              <a:t>Submit deliverable 1 on the website by Sunday 25 October, 23:59 CET.</a:t>
+              <a:t>Submit deliverable 1 on the website by Sunday 1 November, 23:59 CET.</a:t>
             </a:r>
             <a:endParaRPr lang="en-US" sz="1300" dirty="0"/>
           </a:p>
@@ -7905,7 +7905,7 @@
       </p:sp>
       <p:pic>
         <p:nvPicPr>
-          <p:cNvPr id="25" name="Image 5" descr="C:\Users\danir\Desktop\COIL Ulysseus\site\img\team\tamara-backovic.jpg">    </p:cNvPr>
+          <p:cNvPr id="25" name="Image 5" descr="C:\Users\danir\Desktop\COIL Ulysseus\site\img\team\tamara-backovic-ucg.jpg">    </p:cNvPr>
           <p:cNvPicPr>
             <a:picLocks noChangeAspect="1"/>
           </p:cNvPicPr>
@@ -8731,7 +8731,7 @@
                 <a:ea typeface="Calibri" pitchFamily="34" charset="-122"/>
                 <a:cs typeface="Calibri" pitchFamily="34" charset="-120"/>
               </a:rPr>
-              <a:t>Nine weeks, three countries, one data project: compare Spain, Slovakia and Montenegro with the rest of Europe using real data.</a:t>
+              <a:t>Eight weeks, three countries, one data project: compare Spain, Slovakia and Montenegro with the rest of Europe using real data.</a:t>
             </a:r>
             <a:endParaRPr lang="en-US" sz="1150" dirty="0"/>
           </a:p>
@@ -9640,7 +9640,7 @@
                 <a:ea typeface="Calibri" pitchFamily="34" charset="-122"/>
                 <a:cs typeface="Calibri" pitchFamily="34" charset="-120"/>
               </a:rPr>
-              <a:t>Week 9, to all three universities</a:t>
+              <a:t>Week 8, to all three universities</a:t>
             </a:r>
             <a:endParaRPr lang="en-US" sz="1050" dirty="0"/>
           </a:p>
@@ -9839,7 +9839,7 @@
                 <a:ea typeface="Georgia" pitchFamily="34" charset="-122"/>
                 <a:cs typeface="Georgia" pitchFamily="34" charset="-120"/>
               </a:rPr>
-              <a:t>Nine weeks · 12 October – 13 December 2026</a:t>
+              <a:t>Eight weeks · 19 October – 13 December 2026</a:t>
             </a:r>
             <a:endParaRPr lang="en-US" sz="2400" dirty="0"/>
           </a:p>
@@ -9893,7 +9893,7 @@
         <p:spPr>
           <a:xfrm>
             <a:off x="457200" y="1234440"/>
-            <a:ext cx="859536" cy="457200"/>
+            <a:ext cx="973836" cy="457200"/>
           </a:xfrm>
           <a:prstGeom prst="rect">
             <a:avLst/>
@@ -9918,7 +9918,7 @@
         <p:spPr>
           <a:xfrm>
             <a:off x="457200" y="1234440"/>
-            <a:ext cx="859536" cy="457200"/>
+            <a:ext cx="973836" cy="457200"/>
           </a:xfrm>
           <a:prstGeom prst="rect">
             <a:avLst/>
@@ -9957,7 +9957,7 @@
         <p:spPr>
           <a:xfrm>
             <a:off x="457200" y="1737360"/>
-            <a:ext cx="859536" cy="228600"/>
+            <a:ext cx="973836" cy="228600"/>
           </a:xfrm>
           <a:prstGeom prst="rect">
             <a:avLst/>
@@ -9981,7 +9981,7 @@
                 <a:ea typeface="Calibri" pitchFamily="34" charset="-122"/>
                 <a:cs typeface="Calibri" pitchFamily="34" charset="-120"/>
               </a:rPr>
-              <a:t>12 Oct</a:t>
+              <a:t>19 Oct</a:t>
             </a:r>
             <a:endParaRPr lang="en-US" sz="900" dirty="0"/>
           </a:p>
@@ -9996,7 +9996,7 @@
         <p:spPr>
           <a:xfrm>
             <a:off x="475488" y="2011680"/>
-            <a:ext cx="822960" cy="1143000"/>
+            <a:ext cx="937260" cy="1143000"/>
           </a:xfrm>
           <a:prstGeom prst="rect">
             <a:avLst/>
@@ -10037,7 +10037,7 @@
         <p:spPr>
           <a:xfrm>
             <a:off x="530352" y="3154680"/>
-            <a:ext cx="713232" cy="329184"/>
+            <a:ext cx="827532" cy="329184"/>
           </a:xfrm>
           <a:prstGeom prst="roundRect">
             <a:avLst>
@@ -10064,7 +10064,7 @@
         <p:spPr>
           <a:xfrm>
             <a:off x="530352" y="3154680"/>
-            <a:ext cx="713232" cy="329184"/>
+            <a:ext cx="827532" cy="329184"/>
           </a:xfrm>
           <a:prstGeom prst="rect">
             <a:avLst/>
@@ -10102,8 +10102,8 @@
         </p:nvSpPr>
         <p:spPr>
           <a:xfrm>
-            <a:off x="1371600" y="1234440"/>
-            <a:ext cx="859536" cy="457200"/>
+            <a:off x="1485900" y="1234440"/>
+            <a:ext cx="973836" cy="457200"/>
           </a:xfrm>
           <a:prstGeom prst="rect">
             <a:avLst/>
@@ -10127,8 +10127,8 @@
         </p:nvSpPr>
         <p:spPr>
           <a:xfrm>
-            <a:off x="1371600" y="1234440"/>
-            <a:ext cx="859536" cy="457200"/>
+            <a:off x="1485900" y="1234440"/>
+            <a:ext cx="973836" cy="457200"/>
           </a:xfrm>
           <a:prstGeom prst="rect">
             <a:avLst/>
@@ -10166,8 +10166,8 @@
         </p:nvSpPr>
         <p:spPr>
           <a:xfrm>
-            <a:off x="1371600" y="1737360"/>
-            <a:ext cx="859536" cy="228600"/>
+            <a:off x="1485900" y="1737360"/>
+            <a:ext cx="973836" cy="228600"/>
           </a:xfrm>
           <a:prstGeom prst="rect">
             <a:avLst/>
@@ -10191,7 +10191,7 @@
                 <a:ea typeface="Calibri" pitchFamily="34" charset="-122"/>
                 <a:cs typeface="Calibri" pitchFamily="34" charset="-120"/>
               </a:rPr>
-              <a:t>19 Oct</a:t>
+              <a:t>26 Oct</a:t>
             </a:r>
             <a:endParaRPr lang="en-US" sz="900" dirty="0"/>
           </a:p>
@@ -10205,8 +10205,8 @@
         </p:nvSpPr>
         <p:spPr>
           <a:xfrm>
-            <a:off x="1389888" y="2011680"/>
-            <a:ext cx="822960" cy="1143000"/>
+            <a:off x="1504188" y="2011680"/>
+            <a:ext cx="937260" cy="1143000"/>
           </a:xfrm>
           <a:prstGeom prst="rect">
             <a:avLst/>
@@ -10246,8 +10246,8 @@
         </p:nvSpPr>
         <p:spPr>
           <a:xfrm>
-            <a:off x="1444752" y="2743200"/>
-            <a:ext cx="713232" cy="329184"/>
+            <a:off x="1559052" y="2743200"/>
+            <a:ext cx="827532" cy="329184"/>
           </a:xfrm>
           <a:prstGeom prst="roundRect">
             <a:avLst>
@@ -10273,8 +10273,8 @@
         </p:nvSpPr>
         <p:spPr>
           <a:xfrm>
-            <a:off x="1444752" y="2743200"/>
-            <a:ext cx="713232" cy="329184"/>
+            <a:off x="1559052" y="2743200"/>
+            <a:ext cx="827532" cy="329184"/>
           </a:xfrm>
           <a:prstGeom prst="rect">
             <a:avLst/>
@@ -10312,8 +10312,8 @@
         </p:nvSpPr>
         <p:spPr>
           <a:xfrm>
-            <a:off x="2286000" y="1234440"/>
-            <a:ext cx="859536" cy="457200"/>
+            <a:off x="2514600" y="1234440"/>
+            <a:ext cx="973836" cy="457200"/>
           </a:xfrm>
           <a:prstGeom prst="rect">
             <a:avLst/>
@@ -10337,8 +10337,8 @@
         </p:nvSpPr>
         <p:spPr>
           <a:xfrm>
-            <a:off x="2286000" y="1234440"/>
-            <a:ext cx="859536" cy="457200"/>
+            <a:off x="2514600" y="1234440"/>
+            <a:ext cx="973836" cy="457200"/>
           </a:xfrm>
           <a:prstGeom prst="rect">
             <a:avLst/>
@@ -10376,8 +10376,8 @@
         </p:nvSpPr>
         <p:spPr>
           <a:xfrm>
-            <a:off x="2286000" y="1737360"/>
-            <a:ext cx="859536" cy="228600"/>
+            <a:off x="2514600" y="1737360"/>
+            <a:ext cx="973836" cy="228600"/>
           </a:xfrm>
           <a:prstGeom prst="rect">
             <a:avLst/>
@@ -10401,7 +10401,7 @@
                 <a:ea typeface="Calibri" pitchFamily="34" charset="-122"/>
                 <a:cs typeface="Calibri" pitchFamily="34" charset="-120"/>
               </a:rPr>
-              <a:t>26 Oct</a:t>
+              <a:t>2 Nov</a:t>
             </a:r>
             <a:endParaRPr lang="en-US" sz="900" dirty="0"/>
           </a:p>
@@ -10415,8 +10415,8 @@
         </p:nvSpPr>
         <p:spPr>
           <a:xfrm>
-            <a:off x="2304288" y="2011680"/>
-            <a:ext cx="822960" cy="1143000"/>
+            <a:off x="2532888" y="2011680"/>
+            <a:ext cx="937260" cy="1143000"/>
           </a:xfrm>
           <a:prstGeom prst="rect">
             <a:avLst/>
@@ -10456,8 +10456,8 @@
         </p:nvSpPr>
         <p:spPr>
           <a:xfrm>
-            <a:off x="2359152" y="3154680"/>
-            <a:ext cx="713232" cy="329184"/>
+            <a:off x="2587752" y="3154680"/>
+            <a:ext cx="827532" cy="329184"/>
           </a:xfrm>
           <a:prstGeom prst="roundRect">
             <a:avLst>
@@ -10483,8 +10483,8 @@
         </p:nvSpPr>
         <p:spPr>
           <a:xfrm>
-            <a:off x="2359152" y="3154680"/>
-            <a:ext cx="713232" cy="329184"/>
+            <a:off x="2587752" y="3154680"/>
+            <a:ext cx="827532" cy="329184"/>
           </a:xfrm>
           <a:prstGeom prst="rect">
             <a:avLst/>
@@ -10522,8 +10522,8 @@
         </p:nvSpPr>
         <p:spPr>
           <a:xfrm>
-            <a:off x="3200400" y="1234440"/>
-            <a:ext cx="859536" cy="457200"/>
+            <a:off x="3543300" y="1234440"/>
+            <a:ext cx="973836" cy="457200"/>
           </a:xfrm>
           <a:prstGeom prst="rect">
             <a:avLst/>
@@ -10547,8 +10547,8 @@
         </p:nvSpPr>
         <p:spPr>
           <a:xfrm>
-            <a:off x="3200400" y="1234440"/>
-            <a:ext cx="859536" cy="457200"/>
+            <a:off x="3543300" y="1234440"/>
+            <a:ext cx="973836" cy="457200"/>
           </a:xfrm>
           <a:prstGeom prst="rect">
             <a:avLst/>
@@ -10586,8 +10586,8 @@
         </p:nvSpPr>
         <p:spPr>
           <a:xfrm>
-            <a:off x="3200400" y="1737360"/>
-            <a:ext cx="859536" cy="228600"/>
+            <a:off x="3543300" y="1737360"/>
+            <a:ext cx="973836" cy="228600"/>
           </a:xfrm>
           <a:prstGeom prst="rect">
             <a:avLst/>
@@ -10611,7 +10611,7 @@
                 <a:ea typeface="Calibri" pitchFamily="34" charset="-122"/>
                 <a:cs typeface="Calibri" pitchFamily="34" charset="-120"/>
               </a:rPr>
-              <a:t>2 Nov</a:t>
+              <a:t>9 Nov</a:t>
             </a:r>
             <a:endParaRPr lang="en-US" sz="900" dirty="0"/>
           </a:p>
@@ -10625,8 +10625,8 @@
         </p:nvSpPr>
         <p:spPr>
           <a:xfrm>
-            <a:off x="3218688" y="2011680"/>
-            <a:ext cx="822960" cy="1143000"/>
+            <a:off x="3561588" y="2011680"/>
+            <a:ext cx="937260" cy="1143000"/>
           </a:xfrm>
           <a:prstGeom prst="rect">
             <a:avLst/>
@@ -10666,8 +10666,8 @@
         </p:nvSpPr>
         <p:spPr>
           <a:xfrm>
-            <a:off x="4114800" y="1234440"/>
-            <a:ext cx="859536" cy="457200"/>
+            <a:off x="4572000" y="1234440"/>
+            <a:ext cx="973836" cy="457200"/>
           </a:xfrm>
           <a:prstGeom prst="rect">
             <a:avLst/>
@@ -10691,8 +10691,8 @@
         </p:nvSpPr>
         <p:spPr>
           <a:xfrm>
-            <a:off x="4114800" y="1234440"/>
-            <a:ext cx="859536" cy="457200"/>
+            <a:off x="4572000" y="1234440"/>
+            <a:ext cx="973836" cy="457200"/>
           </a:xfrm>
           <a:prstGeom prst="rect">
             <a:avLst/>
@@ -10730,8 +10730,8 @@
         </p:nvSpPr>
         <p:spPr>
           <a:xfrm>
-            <a:off x="4114800" y="1737360"/>
-            <a:ext cx="859536" cy="228600"/>
+            <a:off x="4572000" y="1737360"/>
+            <a:ext cx="973836" cy="228600"/>
           </a:xfrm>
           <a:prstGeom prst="rect">
             <a:avLst/>
@@ -10755,7 +10755,7 @@
                 <a:ea typeface="Calibri" pitchFamily="34" charset="-122"/>
                 <a:cs typeface="Calibri" pitchFamily="34" charset="-120"/>
               </a:rPr>
-              <a:t>9 Nov</a:t>
+              <a:t>16 Nov</a:t>
             </a:r>
             <a:endParaRPr lang="en-US" sz="900" dirty="0"/>
           </a:p>
@@ -10769,8 +10769,8 @@
         </p:nvSpPr>
         <p:spPr>
           <a:xfrm>
-            <a:off x="4133088" y="2011680"/>
-            <a:ext cx="822960" cy="1143000"/>
+            <a:off x="4590288" y="2011680"/>
+            <a:ext cx="937260" cy="1143000"/>
           </a:xfrm>
           <a:prstGeom prst="rect">
             <a:avLst/>
@@ -10810,8 +10810,8 @@
         </p:nvSpPr>
         <p:spPr>
           <a:xfrm>
-            <a:off x="4187952" y="3154680"/>
-            <a:ext cx="713232" cy="329184"/>
+            <a:off x="4645152" y="3154680"/>
+            <a:ext cx="827532" cy="329184"/>
           </a:xfrm>
           <a:prstGeom prst="roundRect">
             <a:avLst>
@@ -10837,8 +10837,8 @@
         </p:nvSpPr>
         <p:spPr>
           <a:xfrm>
-            <a:off x="4187952" y="3154680"/>
-            <a:ext cx="713232" cy="329184"/>
+            <a:off x="4645152" y="3154680"/>
+            <a:ext cx="827532" cy="329184"/>
           </a:xfrm>
           <a:prstGeom prst="rect">
             <a:avLst/>
@@ -10876,8 +10876,8 @@
         </p:nvSpPr>
         <p:spPr>
           <a:xfrm>
-            <a:off x="5029200" y="1234440"/>
-            <a:ext cx="859536" cy="457200"/>
+            <a:off x="5600700" y="1234440"/>
+            <a:ext cx="973836" cy="457200"/>
           </a:xfrm>
           <a:prstGeom prst="rect">
             <a:avLst/>
@@ -10901,8 +10901,8 @@
         </p:nvSpPr>
         <p:spPr>
           <a:xfrm>
-            <a:off x="5029200" y="1234440"/>
-            <a:ext cx="859536" cy="457200"/>
+            <a:off x="5600700" y="1234440"/>
+            <a:ext cx="973836" cy="457200"/>
           </a:xfrm>
           <a:prstGeom prst="rect">
             <a:avLst/>
@@ -10940,8 +10940,8 @@
         </p:nvSpPr>
         <p:spPr>
           <a:xfrm>
-            <a:off x="5029200" y="1737360"/>
-            <a:ext cx="859536" cy="228600"/>
+            <a:off x="5600700" y="1737360"/>
+            <a:ext cx="973836" cy="228600"/>
           </a:xfrm>
           <a:prstGeom prst="rect">
             <a:avLst/>
@@ -10965,7 +10965,7 @@
                 <a:ea typeface="Calibri" pitchFamily="34" charset="-122"/>
                 <a:cs typeface="Calibri" pitchFamily="34" charset="-120"/>
               </a:rPr>
-              <a:t>16 Nov</a:t>
+              <a:t>23 Nov</a:t>
             </a:r>
             <a:endParaRPr lang="en-US" sz="900" dirty="0"/>
           </a:p>
@@ -10979,8 +10979,8 @@
         </p:nvSpPr>
         <p:spPr>
           <a:xfrm>
-            <a:off x="5047488" y="2011680"/>
-            <a:ext cx="822960" cy="1143000"/>
+            <a:off x="5618988" y="2011680"/>
+            <a:ext cx="937260" cy="1143000"/>
           </a:xfrm>
           <a:prstGeom prst="rect">
             <a:avLst/>
@@ -11020,8 +11020,8 @@
         </p:nvSpPr>
         <p:spPr>
           <a:xfrm>
-            <a:off x="5102352" y="2743200"/>
-            <a:ext cx="713232" cy="329184"/>
+            <a:off x="5673852" y="2743200"/>
+            <a:ext cx="827532" cy="329184"/>
           </a:xfrm>
           <a:prstGeom prst="roundRect">
             <a:avLst>
@@ -11047,8 +11047,8 @@
         </p:nvSpPr>
         <p:spPr>
           <a:xfrm>
-            <a:off x="5102352" y="2743200"/>
-            <a:ext cx="713232" cy="329184"/>
+            <a:off x="5673852" y="2743200"/>
+            <a:ext cx="827532" cy="329184"/>
           </a:xfrm>
           <a:prstGeom prst="rect">
             <a:avLst/>
@@ -11086,8 +11086,8 @@
         </p:nvSpPr>
         <p:spPr>
           <a:xfrm>
-            <a:off x="5943600" y="1234440"/>
-            <a:ext cx="859536" cy="457200"/>
+            <a:off x="6629400" y="1234440"/>
+            <a:ext cx="973836" cy="457200"/>
           </a:xfrm>
           <a:prstGeom prst="rect">
             <a:avLst/>
@@ -11111,8 +11111,8 @@
         </p:nvSpPr>
         <p:spPr>
           <a:xfrm>
-            <a:off x="5943600" y="1234440"/>
-            <a:ext cx="859536" cy="457200"/>
+            <a:off x="6629400" y="1234440"/>
+            <a:ext cx="973836" cy="457200"/>
           </a:xfrm>
           <a:prstGeom prst="rect">
             <a:avLst/>
@@ -11150,8 +11150,8 @@
         </p:nvSpPr>
         <p:spPr>
           <a:xfrm>
-            <a:off x="5943600" y="1737360"/>
-            <a:ext cx="859536" cy="228600"/>
+            <a:off x="6629400" y="1737360"/>
+            <a:ext cx="973836" cy="228600"/>
           </a:xfrm>
           <a:prstGeom prst="rect">
             <a:avLst/>
@@ -11175,7 +11175,7 @@
                 <a:ea typeface="Calibri" pitchFamily="34" charset="-122"/>
                 <a:cs typeface="Calibri" pitchFamily="34" charset="-120"/>
               </a:rPr>
-              <a:t>23 Nov</a:t>
+              <a:t>30 Nov</a:t>
             </a:r>
             <a:endParaRPr lang="en-US" sz="900" dirty="0"/>
           </a:p>
@@ -11189,8 +11189,8 @@
         </p:nvSpPr>
         <p:spPr>
           <a:xfrm>
-            <a:off x="5961888" y="2011680"/>
-            <a:ext cx="822960" cy="1143000"/>
+            <a:off x="6647688" y="2011680"/>
+            <a:ext cx="937260" cy="1143000"/>
           </a:xfrm>
           <a:prstGeom prst="rect">
             <a:avLst/>
@@ -11216,7 +11216,7 @@
                 <a:ea typeface="Calibri" pitchFamily="34" charset="-122"/>
                 <a:cs typeface="Calibri" pitchFamily="34" charset="-120"/>
               </a:rPr>
-              <a:t>Dashboards and data storytelling</a:t>
+              <a:t>Dashboard, feedback and rehearsal</a:t>
             </a:r>
             <a:endParaRPr lang="en-US" sz="900" dirty="0"/>
           </a:p>
@@ -11230,152 +11230,8 @@
         </p:nvSpPr>
         <p:spPr>
           <a:xfrm>
-            <a:off x="6858000" y="1234440"/>
-            <a:ext cx="859536" cy="457200"/>
-          </a:xfrm>
-          <a:prstGeom prst="rect">
-            <a:avLst/>
-          </a:prstGeom>
-          <a:solidFill>
-            <a:srgbClr val="6C63A8"/>
-          </a:solidFill>
-          <a:ln w="12700">
-            <a:solidFill>
-              <a:srgbClr val="6C63A8"/>
-            </a:solidFill>
-            <a:prstDash val="solid"/>
-          </a:ln>
-        </p:spPr>
-      </p:sp>
-      <p:sp>
-        <p:nvSpPr>
-          <p:cNvPr id="44" name="Text 42"/>
-          <p:cNvSpPr/>
-          <p:nvPr/>
-        </p:nvSpPr>
-        <p:spPr>
-          <a:xfrm>
-            <a:off x="6858000" y="1234440"/>
-            <a:ext cx="859536" cy="457200"/>
-          </a:xfrm>
-          <a:prstGeom prst="rect">
-            <a:avLst/>
-          </a:prstGeom>
-          <a:noFill/>
-          <a:ln/>
-        </p:spPr>
-        <p:txBody>
-          <a:bodyPr wrap="square" lIns="0" tIns="0" rIns="0" bIns="0" rtlCol="0" anchor="ctr"/>
-          <a:lstStyle/>
-          <a:p>
-            <a:pPr algn="ctr" indent="0" marL="0">
-              <a:buNone/>
-            </a:pPr>
-            <a:r>
-              <a:rPr lang="en-US" sz="1300" b="1" dirty="0">
-                <a:solidFill>
-                  <a:srgbClr val="FFFFFF"/>
-                </a:solidFill>
-                <a:latin typeface="Calibri" pitchFamily="34" charset="0"/>
-                <a:ea typeface="Calibri" pitchFamily="34" charset="-122"/>
-                <a:cs typeface="Calibri" pitchFamily="34" charset="-120"/>
-              </a:rPr>
-              <a:t>W8</a:t>
-            </a:r>
-            <a:endParaRPr lang="en-US" sz="1300" dirty="0"/>
-          </a:p>
-        </p:txBody>
-      </p:sp>
-      <p:sp>
-        <p:nvSpPr>
-          <p:cNvPr id="45" name="Text 43"/>
-          <p:cNvSpPr/>
-          <p:nvPr/>
-        </p:nvSpPr>
-        <p:spPr>
-          <a:xfrm>
-            <a:off x="6858000" y="1737360"/>
-            <a:ext cx="859536" cy="228600"/>
-          </a:xfrm>
-          <a:prstGeom prst="rect">
-            <a:avLst/>
-          </a:prstGeom>
-          <a:noFill/>
-          <a:ln/>
-        </p:spPr>
-        <p:txBody>
-          <a:bodyPr wrap="square" lIns="0" tIns="0" rIns="0" bIns="0" rtlCol="0" anchor="ctr"/>
-          <a:lstStyle/>
-          <a:p>
-            <a:pPr algn="ctr" indent="0" marL="0">
-              <a:buNone/>
-            </a:pPr>
-            <a:r>
-              <a:rPr lang="en-US" sz="900" dirty="0">
-                <a:solidFill>
-                  <a:srgbClr val="6B6880"/>
-                </a:solidFill>
-                <a:latin typeface="Calibri" pitchFamily="34" charset="0"/>
-                <a:ea typeface="Calibri" pitchFamily="34" charset="-122"/>
-                <a:cs typeface="Calibri" pitchFamily="34" charset="-120"/>
-              </a:rPr>
-              <a:t>30 Nov</a:t>
-            </a:r>
-            <a:endParaRPr lang="en-US" sz="900" dirty="0"/>
-          </a:p>
-        </p:txBody>
-      </p:sp>
-      <p:sp>
-        <p:nvSpPr>
-          <p:cNvPr id="46" name="Text 44"/>
-          <p:cNvSpPr/>
-          <p:nvPr/>
-        </p:nvSpPr>
-        <p:spPr>
-          <a:xfrm>
-            <a:off x="6876288" y="2011680"/>
-            <a:ext cx="822960" cy="1143000"/>
-          </a:xfrm>
-          <a:prstGeom prst="rect">
-            <a:avLst/>
-          </a:prstGeom>
-          <a:noFill/>
-          <a:ln/>
-        </p:spPr>
-        <p:txBody>
-          <a:bodyPr wrap="square" lIns="0" tIns="0" rIns="0" bIns="0" rtlCol="0" anchor="t">
-            <a:normAutofit/>
-          </a:bodyPr>
-          <a:lstStyle/>
-          <a:p>
-            <a:pPr algn="ctr" indent="0" marL="0">
-              <a:buNone/>
-            </a:pPr>
-            <a:r>
-              <a:rPr lang="en-US" sz="900" dirty="0">
-                <a:solidFill>
-                  <a:srgbClr val="2B2840"/>
-                </a:solidFill>
-                <a:latin typeface="Calibri" pitchFamily="34" charset="0"/>
-                <a:ea typeface="Calibri" pitchFamily="34" charset="-122"/>
-                <a:cs typeface="Calibri" pitchFamily="34" charset="-120"/>
-              </a:rPr>
-              <a:t>Final dashboard and rehearsal</a:t>
-            </a:r>
-            <a:endParaRPr lang="en-US" sz="900" dirty="0"/>
-          </a:p>
-        </p:txBody>
-      </p:sp>
-      <p:sp>
-        <p:nvSpPr>
-          <p:cNvPr id="47" name="Shape 45"/>
-          <p:cNvSpPr/>
-          <p:nvPr/>
-        </p:nvSpPr>
-        <p:spPr>
-          <a:xfrm>
-            <a:off x="7772400" y="1234440"/>
-            <a:ext cx="859536" cy="457200"/>
+            <a:off x="7658100" y="1234440"/>
+            <a:ext cx="973836" cy="457200"/>
           </a:xfrm>
           <a:prstGeom prst="rect">
             <a:avLst/>
@@ -11393,14 +11249,14 @@
       </p:sp>
       <p:sp>
         <p:nvSpPr>
-          <p:cNvPr id="48" name="Text 46"/>
-          <p:cNvSpPr/>
-          <p:nvPr/>
-        </p:nvSpPr>
-        <p:spPr>
-          <a:xfrm>
-            <a:off x="7772400" y="1234440"/>
-            <a:ext cx="859536" cy="457200"/>
+          <p:cNvPr id="44" name="Text 42"/>
+          <p:cNvSpPr/>
+          <p:nvPr/>
+        </p:nvSpPr>
+        <p:spPr>
+          <a:xfrm>
+            <a:off x="7658100" y="1234440"/>
+            <a:ext cx="973836" cy="457200"/>
           </a:xfrm>
           <a:prstGeom prst="rect">
             <a:avLst/>
@@ -11424,7 +11280,7 @@
                 <a:ea typeface="Calibri" pitchFamily="34" charset="-122"/>
                 <a:cs typeface="Calibri" pitchFamily="34" charset="-120"/>
               </a:rPr>
-              <a:t>W9</a:t>
+              <a:t>W8</a:t>
             </a:r>
             <a:endParaRPr lang="en-US" sz="1300" dirty="0"/>
           </a:p>
@@ -11432,14 +11288,14 @@
       </p:sp>
       <p:sp>
         <p:nvSpPr>
-          <p:cNvPr id="49" name="Text 47"/>
-          <p:cNvSpPr/>
-          <p:nvPr/>
-        </p:nvSpPr>
-        <p:spPr>
-          <a:xfrm>
-            <a:off x="7772400" y="1737360"/>
-            <a:ext cx="859536" cy="228600"/>
+          <p:cNvPr id="45" name="Text 43"/>
+          <p:cNvSpPr/>
+          <p:nvPr/>
+        </p:nvSpPr>
+        <p:spPr>
+          <a:xfrm>
+            <a:off x="7658100" y="1737360"/>
+            <a:ext cx="973836" cy="228600"/>
           </a:xfrm>
           <a:prstGeom prst="rect">
             <a:avLst/>
@@ -11471,14 +11327,14 @@
       </p:sp>
       <p:sp>
         <p:nvSpPr>
-          <p:cNvPr id="50" name="Text 48"/>
-          <p:cNvSpPr/>
-          <p:nvPr/>
-        </p:nvSpPr>
-        <p:spPr>
-          <a:xfrm>
-            <a:off x="7790688" y="2011680"/>
-            <a:ext cx="822960" cy="1143000"/>
+          <p:cNvPr id="46" name="Text 44"/>
+          <p:cNvSpPr/>
+          <p:nvPr/>
+        </p:nvSpPr>
+        <p:spPr>
+          <a:xfrm>
+            <a:off x="7676388" y="2011680"/>
+            <a:ext cx="937260" cy="1143000"/>
           </a:xfrm>
           <a:prstGeom prst="rect">
             <a:avLst/>
@@ -11512,14 +11368,14 @@
       </p:sp>
       <p:sp>
         <p:nvSpPr>
-          <p:cNvPr id="51" name="Shape 49"/>
-          <p:cNvSpPr/>
-          <p:nvPr/>
-        </p:nvSpPr>
-        <p:spPr>
-          <a:xfrm>
-            <a:off x="7845552" y="2743200"/>
-            <a:ext cx="713232" cy="329184"/>
+          <p:cNvPr id="47" name="Shape 45"/>
+          <p:cNvSpPr/>
+          <p:nvPr/>
+        </p:nvSpPr>
+        <p:spPr>
+          <a:xfrm>
+            <a:off x="7731252" y="2743200"/>
+            <a:ext cx="827532" cy="329184"/>
           </a:xfrm>
           <a:prstGeom prst="roundRect">
             <a:avLst>
@@ -11539,14 +11395,14 @@
       </p:sp>
       <p:sp>
         <p:nvSpPr>
-          <p:cNvPr id="52" name="Text 50"/>
-          <p:cNvSpPr/>
-          <p:nvPr/>
-        </p:nvSpPr>
-        <p:spPr>
-          <a:xfrm>
-            <a:off x="7845552" y="2743200"/>
-            <a:ext cx="713232" cy="329184"/>
+          <p:cNvPr id="48" name="Text 46"/>
+          <p:cNvSpPr/>
+          <p:nvPr/>
+        </p:nvSpPr>
+        <p:spPr>
+          <a:xfrm>
+            <a:off x="7731252" y="2743200"/>
+            <a:ext cx="827532" cy="329184"/>
           </a:xfrm>
           <a:prstGeom prst="rect">
             <a:avLst/>
@@ -11578,14 +11434,14 @@
       </p:sp>
       <p:sp>
         <p:nvSpPr>
-          <p:cNvPr id="53" name="Shape 51"/>
-          <p:cNvSpPr/>
-          <p:nvPr/>
-        </p:nvSpPr>
-        <p:spPr>
-          <a:xfrm>
-            <a:off x="7845552" y="3154680"/>
-            <a:ext cx="713232" cy="329184"/>
+          <p:cNvPr id="49" name="Shape 47"/>
+          <p:cNvSpPr/>
+          <p:nvPr/>
+        </p:nvSpPr>
+        <p:spPr>
+          <a:xfrm>
+            <a:off x="7731252" y="3154680"/>
+            <a:ext cx="827532" cy="329184"/>
           </a:xfrm>
           <a:prstGeom prst="roundRect">
             <a:avLst>
@@ -11605,14 +11461,14 @@
       </p:sp>
       <p:sp>
         <p:nvSpPr>
-          <p:cNvPr id="54" name="Text 52"/>
-          <p:cNvSpPr/>
-          <p:nvPr/>
-        </p:nvSpPr>
-        <p:spPr>
-          <a:xfrm>
-            <a:off x="7845552" y="3154680"/>
-            <a:ext cx="713232" cy="329184"/>
+          <p:cNvPr id="50" name="Text 48"/>
+          <p:cNvSpPr/>
+          <p:nvPr/>
+        </p:nvSpPr>
+        <p:spPr>
+          <a:xfrm>
+            <a:off x="7731252" y="3154680"/>
+            <a:ext cx="827532" cy="329184"/>
           </a:xfrm>
           <a:prstGeom prst="rect">
             <a:avLst/>
@@ -11644,7 +11500,7 @@
       </p:sp>
       <p:sp>
         <p:nvSpPr>
-          <p:cNvPr id="55" name="Text 53"/>
+          <p:cNvPr id="51" name="Text 49"/>
           <p:cNvSpPr/>
           <p:nvPr/>
         </p:nvSpPr>
@@ -12026,7 +11882,7 @@
                 <a:ea typeface="Calibri" pitchFamily="34" charset="-122"/>
                 <a:cs typeface="Calibri" pitchFamily="34" charset="-120"/>
               </a:rPr>
-              <a:t>Sunday 25 October</a:t>
+              <a:t>Sunday 1 November</a:t>
             </a:r>
             <a:endParaRPr lang="en-US" sz="1100" dirty="0"/>
           </a:p>
@@ -12303,7 +12159,7 @@
                 <a:ea typeface="Calibri" pitchFamily="34" charset="-122"/>
                 <a:cs typeface="Calibri" pitchFamily="34" charset="-120"/>
               </a:rPr>
-              <a:t>Sunday 22 November</a:t>
+              <a:t>Sunday 29 November</a:t>
             </a:r>
             <a:endParaRPr lang="en-US" sz="1100" dirty="0"/>
           </a:p>
@@ -12563,7 +12419,7 @@
                 <a:ea typeface="Calibri" pitchFamily="34" charset="-122"/>
                 <a:cs typeface="Calibri" pitchFamily="34" charset="-120"/>
               </a:rPr>
-              <a:t>Week 9</a:t>
+              <a:t>Week 8</a:t>
             </a:r>
             <a:endParaRPr lang="en-US" sz="1100" dirty="0"/>
           </a:p>
@@ -12863,7 +12719,7 @@
                 <a:ea typeface="Calibri" pitchFamily="34" charset="-122"/>
                 <a:cs typeface="Calibri" pitchFamily="34" charset="-120"/>
               </a:rPr>
-              <a:t>DUE SUNDAY 25 OCTOBER, 23:59 CET</a:t>
+              <a:t>DUE SUNDAY 1 NOVEMBER, 23:59 CET</a:t>
             </a:r>
             <a:endParaRPr lang="en-US" sz="1000" dirty="0"/>
           </a:p>

</xml_diff>

<commit_message>
feat(site): Word template for all deliverables and simpler file lists
One Word template (deliverable 1, report of deliverable 2, final reflection) built from content.js,
plus the PowerPoint template for the slides; the dashboard goes on slide 5 instead of a separate file.

Co-Authored-By: Claude Opus 5.5 (1M context) <noreply@anthropic.com>
</commit_message>
<xml_diff>
--- a/docs/slides/COIL_1_kickoff.pptx
+++ b/docs/slides/COIL_1_kickoff.pptx
@@ -12007,7 +12007,7 @@
                 <a:ea typeface="Calibri" pitchFamily="34" charset="-122"/>
                 <a:cs typeface="Calibri" pitchFamily="34" charset="-120"/>
               </a:rPr>
-              <a:t>One PDF, maximum 2 pages (use the templates in the Submit section)</a:t>
+              <a:t>One PDF made with the Word template (Submit section), maximum 2 pages</a:t>
             </a:r>
             <a:endParaRPr lang="en-US" sz="1000" dirty="0"/>
           </a:p>
@@ -12198,7 +12198,7 @@
                 <a:ea typeface="Calibri" pitchFamily="34" charset="-122"/>
                 <a:cs typeface="Calibri" pitchFamily="34" charset="-120"/>
               </a:rPr>
-              <a:t>Analysis notebook</a:t>
+              <a:t>Analysis report</a:t>
             </a:r>
             <a:endParaRPr lang="en-US" sz="1300" dirty="0"/>
           </a:p>
@@ -12284,7 +12284,7 @@
                 <a:ea typeface="Calibri" pitchFamily="34" charset="-122"/>
                 <a:cs typeface="Calibri" pitchFamily="34" charset="-120"/>
               </a:rPr>
-              <a:t>Your analysis file (Python or R notebook, Gretl script or session, or Power BI file) + a PDF or HTML report with all results + your dataset (CSV or Excel)</a:t>
+              <a:t>Report made with the Word template, saved as PDF + your analysis file (Python or R notebook, Gretl script or Power BI file). Add your dataset only if you used data from outside the COIL dataset</a:t>
             </a:r>
             <a:endParaRPr lang="en-US" sz="1000" dirty="0"/>
           </a:p>
@@ -12475,7 +12475,7 @@
                 <a:ea typeface="Calibri" pitchFamily="34" charset="-122"/>
                 <a:cs typeface="Calibri" pitchFamily="34" charset="-120"/>
               </a:rPr>
-              <a:t>Final dashboard, presentation and final reflection</a:t>
+              <a:t>Final presentation and reflection</a:t>
             </a:r>
             <a:endParaRPr lang="en-US" sz="1300" dirty="0"/>
           </a:p>
@@ -12530,7 +12530,7 @@
                 <a:ea typeface="Calibri" pitchFamily="34" charset="-122"/>
                 <a:cs typeface="Calibri" pitchFamily="34" charset="-120"/>
               </a:rPr>
-              <a:t>Team (dashboard, slides and presentation) + individual (reflection)</a:t>
+              <a:t>Team (slides and presentation) + individual (reflection)</a:t>
             </a:r>
             <a:endParaRPr lang="en-US" sz="1000" dirty="0"/>
           </a:p>
@@ -12561,7 +12561,7 @@
                 <a:ea typeface="Calibri" pitchFamily="34" charset="-122"/>
                 <a:cs typeface="Calibri" pitchFamily="34" charset="-120"/>
               </a:rPr>
-              <a:t>Dashboard link or PDF + slides (maximum 6 slides, 5-minute presentation) + one-page PDF reflection</a:t>
+              <a:t>Slides made with the PowerPoint template (maximum 6 slides, 5-minute presentation, dashboard on slide 5) + one-page individual reflection made with the Word template, saved as PDF</a:t>
             </a:r>
             <a:endParaRPr lang="en-US" sz="1000" dirty="0"/>
           </a:p>
@@ -13123,7 +13123,7 @@
                 <a:ea typeface="Calibri" pitchFamily="34" charset="-122"/>
                 <a:cs typeface="Calibri" pitchFamily="34" charset="-120"/>
               </a:rPr>
-              <a:t>One PDF, maximum 2 pages (use the templates in the Submit section)</a:t>
+              <a:t>One PDF made with the Word template (Submit section), maximum 2 pages</a:t>
             </a:r>
             <a:endParaRPr lang="en-US" sz="1150" dirty="0"/>
           </a:p>

</xml_diff>